<commit_message>
feat: implement light/dark theme toggle with persistence
- Added a three-state theme control (light, dark, system) in the sidebar footer.
- Introduced theme preference management using localStorage and matchMedia.
- Created a no-flash script to apply the theme before the first paint.
- Updated layout to include the theme toggle and suppress hydration warnings.
- Refactored button styles to accommodate theme changes.
- Enhanced testing coverage for theme preference logic and script functionality.
- Documented the theme implementation strategy and verification process.
</commit_message>
<xml_diff>
--- a/docs/AI_WORKFLOW_DECK.pptx
+++ b/docs/AI_WORKFLOW_DECK.pptx
@@ -1306,7 +1306,7 @@
           <a:p>
             <a:r>
               <a:rPr lang="en-US" dirty="0"/>
-              <a:t>Nine defects, grouped by where they live. The grouping is the point — they cluster at boundaries, not in the main path.</a:t>
+              <a:t>Eleven defects, grouped by where they live. The grouping is the point — they cluster at boundaries, not in the main path.</a:t>
             </a:r>
             <a:endParaRPr lang="en-US" dirty="0"/>
           </a:p>
@@ -2120,7 +2120,7 @@
                 <a:ea typeface="Calibri" pitchFamily="34" charset="-122"/>
                 <a:cs typeface="Calibri" pitchFamily="34" charset="-120"/>
               </a:rPr>
-              <a:t>9 DEFECTS FOUND</a:t>
+              <a:t>11 DEFECTS FOUND</a:t>
             </a:r>
             <a:endParaRPr lang="en-US" sz="1050" dirty="0"/>
           </a:p>
@@ -2186,7 +2186,7 @@
                 <a:ea typeface="Calibri" pitchFamily="34" charset="-122"/>
                 <a:cs typeface="Calibri" pitchFamily="34" charset="-120"/>
               </a:rPr>
-              <a:t>219 TESTS</a:t>
+              <a:t>237 TESTS</a:t>
             </a:r>
             <a:endParaRPr lang="en-US" sz="1050" dirty="0"/>
           </a:p>
@@ -7695,7 +7695,7 @@
                 <a:ea typeface="Cambria" pitchFamily="34" charset="-122"/>
                 <a:cs typeface="Cambria" pitchFamily="34" charset="-120"/>
               </a:rPr>
-              <a:t>219</a:t>
+              <a:t>237</a:t>
             </a:r>
             <a:endParaRPr lang="en-US" sz="4000" dirty="0"/>
           </a:p>
@@ -7734,7 +7734,7 @@
                 <a:ea typeface="Calibri" pitchFamily="34" charset="-122"/>
                 <a:cs typeface="Calibri" pitchFamily="34" charset="-120"/>
               </a:rPr>
-              <a:t>tests, 7 files</a:t>
+              <a:t>tests, 8 files</a:t>
             </a:r>
             <a:endParaRPr lang="en-US" sz="1300" dirty="0"/>
           </a:p>
@@ -7773,7 +7773,7 @@
                 <a:ea typeface="Cambria" pitchFamily="34" charset="-122"/>
                 <a:cs typeface="Cambria" pitchFamily="34" charset="-120"/>
               </a:rPr>
-              <a:t>2,300</a:t>
+              <a:t>2,423</a:t>
             </a:r>
             <a:endParaRPr lang="en-US" sz="4000" dirty="0"/>
           </a:p>
@@ -7851,7 +7851,7 @@
                 <a:ea typeface="Cambria" pitchFamily="34" charset="-122"/>
                 <a:cs typeface="Cambria" pitchFamily="34" charset="-120"/>
               </a:rPr>
-              <a:t>8,200</a:t>
+              <a:t>8,267</a:t>
             </a:r>
             <a:endParaRPr lang="en-US" sz="4000" dirty="0"/>
           </a:p>
@@ -8000,7 +8000,7 @@
                 <a:ea typeface="Cambria" pitchFamily="34" charset="-122"/>
                 <a:cs typeface="Cambria" pitchFamily="34" charset="-120"/>
               </a:rPr>
-              <a:t>Nine defects — all in code that looked correct</a:t>
+              <a:t>Eleven defects — all in code that looked correct</a:t>
             </a:r>
             <a:endParaRPr lang="en-US" sz="3400" dirty="0"/>
           </a:p>
@@ -8498,7 +8498,7 @@
                 <a:ea typeface="Cambria" pitchFamily="34" charset="-122"/>
                 <a:cs typeface="Cambria" pitchFamily="34" charset="-120"/>
               </a:rPr>
-              <a:t>2</a:t>
+              <a:t>4</a:t>
             </a:r>
             <a:endParaRPr lang="en-US" sz="5200" dirty="0"/>
           </a:p>
@@ -8537,7 +8537,7 @@
                 <a:ea typeface="Calibri" pitchFamily="34" charset="-122"/>
                 <a:cs typeface="Calibri" pitchFamily="34" charset="-120"/>
               </a:rPr>
-              <a:t>Concurrency &amp; React</a:t>
+              <a:t>Concurrency &amp; the DOM</a:t>
             </a:r>
             <a:endParaRPr lang="en-US" sz="1500" dirty="0"/>
           </a:p>
@@ -8576,7 +8576,7 @@
                 <a:ea typeface="Calibri" pitchFamily="34" charset="-122"/>
                 <a:cs typeface="Calibri" pitchFamily="34" charset="-120"/>
               </a:rPr>
-              <a:t>Overwrite-on-refresh, effect violations</a:t>
+              <a:t>Overwrite-on-refresh, effect violations, a stale media listener, hover beating checked</a:t>
             </a:r>
             <a:endParaRPr lang="en-US" sz="1200" dirty="0"/>
           </a:p>

</xml_diff>